<commit_message>
Fix department name: Bioscience and Biotechnology (was Biochemical Engineering)
Corrected in BTP2_REPORT.md (title page + certificate), generate_btp2_ppt.py
(title slide + thank you slide). Regenerated BTP2_REPORT.pdf and BTP2_KGMiner.pptx.

Co-Authored-By: Claude Sonnet 4.6 <noreply@anthropic.com>
</commit_message>
<xml_diff>
--- a/BTP2_KGMiner.pptx
+++ b/BTP2_KGMiner.pptx
@@ -3340,7 +3340,7 @@
                 <a:latin typeface="Calibri"/>
               </a:rPr>
               <a:t>Upanshu Jain  |  Roll No: 22BT10035
-Dept. of Biotechnology &amp; Biochemical Engineering</a:t>
+Dept. of Bioscience and Biotechnology</a:t>
             </a:r>
           </a:p>
         </p:txBody>
@@ -20950,7 +20950,7 @@
                 <a:latin typeface="Calibri"/>
               </a:rPr>
               <a:t>Upanshu Jain  |  Roll: 22BT10035
-Dept. of Biotechnology &amp; Biochemical Engineering</a:t>
+Dept. of Bioscience and Biotechnology</a:t>
             </a:r>
           </a:p>
         </p:txBody>

</xml_diff>